<commit_message>
Update Word docs and PPTX decks with current app state and June 2026 learnings
- Correct stats throughout: 47 concepts / 59 relations / 10 tiers (the
  June 12 ontology rebuild), 701 shlokas, 18 chapters, 4 languages -
  replacing stale 112-117/124-239/12-13 figures
- Document new phases: ontology rebuild (strict verse-grounding), OCR
  cleanup of bannanje_kn.js (~265 garbled English terms, 476 pages
  verified zero-error), the June 18-21 book-alignment marathon (514+
  boundary leaks fixed, all 18 chapters re-verified, homorganic nasal
  transliteration), and bundle consolidation (viewer-bundled.html trio
  retired in favor of viewer.html + index.html)
- Document new Map feature: Adhyaya/Shloka filter dropdowns
- Fix all app links from retired viewer-bundled.html to viewer.html
- Update USD-INR reference rate to June 2026
- Add new 'Phases 7-10' slide and swap a Hard Problems card in the
  Technical Journey deck
</commit_message>
<xml_diff>
--- a/Tatvam_Jalam_Technical_Journey-3.pptx
+++ b/Tatvam_Jalam_Technical_Journey-3.pptx
@@ -16,6 +16,7 @@
     <p:sldId id="261" r:id="rId7"/>
     <p:sldId id="262" r:id="rId8"/>
     <p:sldId id="263" r:id="rId9"/>
+    <p:sldId id="268" r:id="rId19"/>
     <p:sldId id="264" r:id="rId10"/>
     <p:sldId id="265" r:id="rId11"/>
     <p:sldId id="266" r:id="rId12"/>
@@ -5753,7 +5754,7 @@
                 <a:latin typeface="Calibri"/>
                 <a:ea typeface="Calibri"/>
               </a:rPr>
-              <a:t>Public + private bundle strategy</a:t>
+              <a:t>viewer.html (single-file) + index.html (modular)</a:t>
             </a:r>
             <a:endParaRPr lang="en-US" sz="900" b="0" strike="noStrike" spc="-1">
               <a:solidFill>
@@ -5992,7 +5993,7 @@
                 <a:latin typeface="Calibri"/>
                 <a:ea typeface="Calibri"/>
               </a:rPr>
-              <a:t>Python / sed — surgical file patching</a:t>
+              <a:t>verify.py / verify.js — parse &amp; integrity checks</a:t>
             </a:r>
             <a:endParaRPr lang="en-US" sz="900" b="0" strike="noStrike" spc="-1">
               <a:solidFill>
@@ -6020,7 +6021,7 @@
                 <a:latin typeface="Calibri"/>
                 <a:ea typeface="Calibri"/>
               </a:rPr>
-              <a:t>Node.js — syntax validation after each patch</a:t>
+              <a:t>Playwright — visual QA across all 5 views × 4 languages</a:t>
             </a:r>
             <a:endParaRPr lang="en-US" sz="900" b="0" strike="noStrike" spc="-1">
               <a:solidFill>
@@ -6381,7 +6382,7 @@
                 <a:latin typeface="Calibri"/>
                 <a:ea typeface="Calibri"/>
               </a:rPr>
-              <a:t>Complete Shloka Extraction</a:t>
+              <a:t>Resolve 11.52–11.55 Gap</a:t>
             </a:r>
             <a:endParaRPr lang="en-US" sz="1100" b="0" strike="noStrike" spc="-1">
               <a:solidFill>
@@ -6445,7 +6446,7 @@
                 <a:latin typeface="Calibri"/>
                 <a:ea typeface="Calibri"/>
               </a:rPr>
-              <a:t>All 702 shlokas extracted and verified across all 18 chapters.</a:t>
+              <a:t>Pages 392–393 of the book contain all four verses; current placeholder notes in bannanje_kn.js are wrong and need correcting — a digitisation failure, not a genuine source gap.</a:t>
             </a:r>
             <a:endParaRPr lang="en-US" sz="850" b="0" strike="noStrike" spc="-1">
               <a:solidFill>
@@ -7377,7 +7378,7 @@
                 <a:latin typeface="Calibri"/>
                 <a:ea typeface="Calibri"/>
               </a:rPr>
-              <a:t>Usage Analytics</a:t>
+              <a:t>Refresh Stale Docs</a:t>
             </a:r>
             <a:endParaRPr lang="en-US" sz="1100" b="0" strike="noStrike" spc="-1">
               <a:solidFill>
@@ -7441,7 +7442,7 @@
                 <a:latin typeface="Calibri"/>
                 <a:ea typeface="Calibri"/>
               </a:rPr>
-              <a:t>Understand which concepts and chapters are most explored to guide further commentary depth and data enrichment.</a:t>
+              <a:t>README.md, PROJECT_STATUS.md, and _state.txt still cite the pre-rebuild 112-concept / 124-relation / 12-tier ontology — update to match the live 47 / 59 / 10 in data.js.</a:t>
             </a:r>
             <a:endParaRPr lang="en-US" sz="850" b="0" strike="noStrike" spc="-1">
               <a:solidFill>
@@ -8258,7 +8259,7 @@
                 <a:latin typeface="Calibri"/>
                 <a:ea typeface="Calibri"/>
               </a:rPr>
-              <a:t>🌐  kvinayakpai.github.io/Bhagavadgita/viewer-bundled.html</a:t>
+              <a:t>🌐  kvinayakpai.github.io/Bhagavadgita/viewer.html</a:t>
             </a:r>
             <a:endParaRPr lang="en-US" sz="1100" b="0" strike="noStrike" spc="-1">
               <a:solidFill>
@@ -8389,6 +8390,1842 @@
               <a:t>Madhva · Dvaita Vedānta · Bannanje Govindacharya Tradition</a:t>
             </a:r>
             <a:endParaRPr lang="en-US" sz="950" b="0" strike="noStrike" spc="-1">
+              <a:solidFill>
+                <a:srgbClr val="FFFFFF"/>
+              </a:solidFill>
+              <a:latin typeface="Arial"/>
+            </a:endParaRPr>
+          </a:p>
+        </p:txBody>
+      </p:sp>
+    </p:spTree>
+  </p:cSld>
+  <p:clrMapOvr>
+    <a:masterClrMapping/>
+  </p:clrMapOvr>
+</p:sld>
+</file>
+
+<file path=ppt/slides/slide13.xml><?xml version="1.0" encoding="utf-8"?>
+<p:sld xmlns:a="http://schemas.openxmlformats.org/drawingml/2006/main" xmlns:r="http://schemas.openxmlformats.org/officeDocument/2006/relationships" xmlns:p="http://schemas.openxmlformats.org/presentationml/2006/main">
+  <p:cSld>
+    <p:bg>
+      <p:bgPr>
+        <a:solidFill>
+          <a:srgbClr val="1A2744"/>
+        </a:solidFill>
+        <a:effectLst/>
+      </p:bgPr>
+    </p:bg>
+    <p:spTree>
+      <p:nvGrpSpPr>
+        <p:cNvPr id="1" name=""/>
+        <p:cNvGrpSpPr/>
+        <p:nvPr/>
+      </p:nvGrpSpPr>
+      <p:grpSpPr>
+        <a:xfrm>
+          <a:off x="0" y="0"/>
+          <a:ext cx="0" cy="0"/>
+          <a:chOff x="0" y="0"/>
+          <a:chExt cx="0" cy="0"/>
+        </a:xfrm>
+      </p:grpSpPr>
+      <p:sp>
+        <p:nvSpPr>
+          <p:cNvPr id="126" name="Shape 0"/>
+          <p:cNvSpPr/>
+          <p:nvPr/>
+        </p:nvSpPr>
+        <p:spPr>
+          <a:xfrm>
+            <a:off x="0" y="0"/>
+            <a:ext cx="9143640" cy="54360"/>
+          </a:xfrm>
+          <a:prstGeom prst="rect">
+            <a:avLst/>
+          </a:prstGeom>
+          <a:solidFill>
+            <a:srgbClr val="C17A2E"/>
+          </a:solidFill>
+          <a:ln w="12700">
+            <a:solidFill>
+              <a:srgbClr val="C17A2E"/>
+            </a:solidFill>
+            <a:round/>
+          </a:ln>
+        </p:spPr>
+        <p:style>
+          <a:lnRef idx="0">
+            <a:scrgbClr r="0" g="0" b="0"/>
+          </a:lnRef>
+          <a:fillRef idx="0">
+            <a:scrgbClr r="0" g="0" b="0"/>
+          </a:fillRef>
+          <a:effectRef idx="0">
+            <a:scrgbClr r="0" g="0" b="0"/>
+          </a:effectRef>
+          <a:fontRef idx="minor"/>
+        </p:style>
+        <p:txBody>
+          <a:bodyPr lIns="90000" tIns="9720" rIns="90000" bIns="9720" anchor="t">
+            <a:noAutofit/>
+          </a:bodyPr>
+          <a:lstStyle/>
+          <a:p>
+            <a:endParaRPr lang="en-US" sz="1800" b="0" strike="noStrike" spc="-1">
+              <a:solidFill>
+                <a:srgbClr val="FFFFFF"/>
+              </a:solidFill>
+              <a:latin typeface="Arial"/>
+            </a:endParaRPr>
+          </a:p>
+        </p:txBody>
+      </p:sp>
+      <p:sp>
+        <p:nvSpPr>
+          <p:cNvPr id="127" name="Text 1"/>
+          <p:cNvSpPr/>
+          <p:nvPr/>
+        </p:nvSpPr>
+        <p:spPr>
+          <a:xfrm>
+            <a:off x="457200" y="164520"/>
+            <a:ext cx="8229240" cy="594000"/>
+          </a:xfrm>
+          <a:prstGeom prst="rect">
+            <a:avLst/>
+          </a:prstGeom>
+          <a:noFill/>
+          <a:ln w="0">
+            <a:noFill/>
+          </a:ln>
+        </p:spPr>
+        <p:style>
+          <a:lnRef idx="0">
+            <a:scrgbClr r="0" g="0" b="0"/>
+          </a:lnRef>
+          <a:fillRef idx="0">
+            <a:scrgbClr r="0" g="0" b="0"/>
+          </a:fillRef>
+          <a:effectRef idx="0">
+            <a:scrgbClr r="0" g="0" b="0"/>
+          </a:effectRef>
+          <a:fontRef idx="minor"/>
+        </p:style>
+        <p:txBody>
+          <a:bodyPr lIns="90000" tIns="45000" rIns="90000" bIns="45000" anchor="ctr">
+            <a:noAutofit/>
+          </a:bodyPr>
+          <a:lstStyle/>
+          <a:p>
+            <a:pPr defTabSz="914400">
+              <a:lnSpc>
+                <a:spcPct val="100000"/>
+              </a:lnSpc>
+              <a:tabLst>
+                <a:tab pos="0" algn="l"/>
+              </a:tabLst>
+            </a:pPr>
+            <a:r>
+              <a:rPr lang="en-US" sz="2600" b="1" strike="noStrike" spc="-1">
+                <a:solidFill>
+                  <a:srgbClr val="FFFFFF"/>
+                </a:solidFill>
+                <a:latin typeface="Georgia"/>
+                <a:ea typeface="Georgia"/>
+              </a:rPr>
+              <a:t>Phases 7–10 — From Features to Fidelity</a:t>
+            </a:r>
+            <a:endParaRPr lang="en-US" sz="2600" b="0" strike="noStrike" spc="-1">
+              <a:solidFill>
+                <a:srgbClr val="FFFFFF"/>
+              </a:solidFill>
+              <a:latin typeface="Arial"/>
+            </a:endParaRPr>
+          </a:p>
+        </p:txBody>
+      </p:sp>
+      <p:sp>
+        <p:nvSpPr>
+          <p:cNvPr id="128" name="Shape 2"/>
+          <p:cNvSpPr/>
+          <p:nvPr/>
+        </p:nvSpPr>
+        <p:spPr>
+          <a:xfrm>
+            <a:off x="365760" y="1097280"/>
+            <a:ext cx="255600" cy="255600"/>
+          </a:xfrm>
+          <a:prstGeom prst="ellipse">
+            <a:avLst/>
+          </a:prstGeom>
+          <a:solidFill>
+            <a:srgbClr val="C17A2E"/>
+          </a:solidFill>
+          <a:ln w="12700">
+            <a:solidFill>
+              <a:srgbClr val="C17A2E"/>
+            </a:solidFill>
+            <a:round/>
+          </a:ln>
+        </p:spPr>
+        <p:style>
+          <a:lnRef idx="0">
+            <a:scrgbClr r="0" g="0" b="0"/>
+          </a:lnRef>
+          <a:fillRef idx="0">
+            <a:scrgbClr r="0" g="0" b="0"/>
+          </a:fillRef>
+          <a:effectRef idx="0">
+            <a:scrgbClr r="0" g="0" b="0"/>
+          </a:effectRef>
+          <a:fontRef idx="minor"/>
+        </p:style>
+        <p:txBody>
+          <a:bodyPr lIns="90000" tIns="45000" rIns="90000" bIns="45000" anchor="t">
+            <a:noAutofit/>
+          </a:bodyPr>
+          <a:lstStyle/>
+          <a:p>
+            <a:endParaRPr lang="en-US" sz="1800" b="0" strike="noStrike" spc="-1">
+              <a:solidFill>
+                <a:srgbClr val="FFFFFF"/>
+              </a:solidFill>
+              <a:latin typeface="Arial"/>
+            </a:endParaRPr>
+          </a:p>
+        </p:txBody>
+      </p:sp>
+      <p:sp>
+        <p:nvSpPr>
+          <p:cNvPr id="129" name="Text 3"/>
+          <p:cNvSpPr/>
+          <p:nvPr/>
+        </p:nvSpPr>
+        <p:spPr>
+          <a:xfrm>
+            <a:off x="713160" y="1051560"/>
+            <a:ext cx="4114440" cy="273960"/>
+          </a:xfrm>
+          <a:prstGeom prst="rect">
+            <a:avLst/>
+          </a:prstGeom>
+          <a:noFill/>
+          <a:ln w="0">
+            <a:noFill/>
+          </a:ln>
+        </p:spPr>
+        <p:style>
+          <a:lnRef idx="0">
+            <a:scrgbClr r="0" g="0" b="0"/>
+          </a:lnRef>
+          <a:fillRef idx="0">
+            <a:scrgbClr r="0" g="0" b="0"/>
+          </a:fillRef>
+          <a:effectRef idx="0">
+            <a:scrgbClr r="0" g="0" b="0"/>
+          </a:effectRef>
+          <a:fontRef idx="minor"/>
+        </p:style>
+        <p:txBody>
+          <a:bodyPr lIns="0" tIns="0" rIns="0" bIns="0" anchor="ctr">
+            <a:noAutofit/>
+          </a:bodyPr>
+          <a:lstStyle/>
+          <a:p>
+            <a:pPr defTabSz="914400">
+              <a:lnSpc>
+                <a:spcPct val="100000"/>
+              </a:lnSpc>
+              <a:tabLst>
+                <a:tab pos="0" algn="l"/>
+              </a:tabLst>
+            </a:pPr>
+            <a:r>
+              <a:rPr lang="en-US" sz="1100" b="1" strike="noStrike" spc="-1">
+                <a:solidFill>
+                  <a:srgbClr val="E8A828"/>
+                </a:solidFill>
+                <a:latin typeface="Calibri"/>
+                <a:ea typeface="Calibri"/>
+              </a:rPr>
+              <a:t>Ontology Rebuild</a:t>
+            </a:r>
+            <a:endParaRPr lang="en-US" sz="1100" b="0" strike="noStrike" spc="-1">
+              <a:solidFill>
+                <a:srgbClr val="FFFFFF"/>
+              </a:solidFill>
+              <a:latin typeface="Arial"/>
+            </a:endParaRPr>
+          </a:p>
+        </p:txBody>
+      </p:sp>
+      <p:sp>
+        <p:nvSpPr>
+          <p:cNvPr id="130" name="Text 4"/>
+          <p:cNvSpPr/>
+          <p:nvPr/>
+        </p:nvSpPr>
+        <p:spPr>
+          <a:xfrm>
+            <a:off x="713160" y="1307520"/>
+            <a:ext cx="4114440" cy="548280"/>
+          </a:xfrm>
+          <a:prstGeom prst="rect">
+            <a:avLst/>
+          </a:prstGeom>
+          <a:noFill/>
+          <a:ln w="0">
+            <a:noFill/>
+          </a:ln>
+        </p:spPr>
+        <p:style>
+          <a:lnRef idx="0">
+            <a:scrgbClr r="0" g="0" b="0"/>
+          </a:lnRef>
+          <a:fillRef idx="0">
+            <a:scrgbClr r="0" g="0" b="0"/>
+          </a:fillRef>
+          <a:effectRef idx="0">
+            <a:scrgbClr r="0" g="0" b="0"/>
+          </a:effectRef>
+          <a:fontRef idx="minor"/>
+        </p:style>
+        <p:txBody>
+          <a:bodyPr lIns="0" tIns="0" rIns="0" bIns="0" anchor="ctr">
+            <a:noAutofit/>
+          </a:bodyPr>
+          <a:lstStyle/>
+          <a:p>
+            <a:pPr defTabSz="914400">
+              <a:lnSpc>
+                <a:spcPct val="100000"/>
+              </a:lnSpc>
+              <a:tabLst>
+                <a:tab pos="0" algn="l"/>
+              </a:tabLst>
+            </a:pPr>
+            <a:r>
+              <a:rPr lang="en-US" sz="950" b="0" strike="noStrike" spc="-1">
+                <a:solidFill>
+                  <a:srgbClr val="8892A4"/>
+                </a:solidFill>
+                <a:latin typeface="Calibri"/>
+                <a:ea typeface="Calibri"/>
+              </a:rPr>
+              <a:t>112 → 47 concepts, 124 → 59 relations, 12 → 10 tiers — every node now anchored to one citable verse in Bannanje's commentary (June 12).</a:t>
+            </a:r>
+            <a:endParaRPr lang="en-US" sz="950" b="0" strike="noStrike" spc="-1">
+              <a:solidFill>
+                <a:srgbClr val="FFFFFF"/>
+              </a:solidFill>
+              <a:latin typeface="Arial"/>
+            </a:endParaRPr>
+          </a:p>
+        </p:txBody>
+      </p:sp>
+      <p:sp>
+        <p:nvSpPr>
+          <p:cNvPr id="131" name="Shape 5"/>
+          <p:cNvSpPr/>
+          <p:nvPr/>
+        </p:nvSpPr>
+        <p:spPr>
+          <a:xfrm>
+            <a:off x="365760" y="2057400"/>
+            <a:ext cx="255600" cy="255600"/>
+          </a:xfrm>
+          <a:prstGeom prst="ellipse">
+            <a:avLst/>
+          </a:prstGeom>
+          <a:solidFill>
+            <a:srgbClr val="C17A2E"/>
+          </a:solidFill>
+          <a:ln w="12700">
+            <a:solidFill>
+              <a:srgbClr val="C17A2E"/>
+            </a:solidFill>
+            <a:round/>
+          </a:ln>
+        </p:spPr>
+        <p:style>
+          <a:lnRef idx="0">
+            <a:scrgbClr r="0" g="0" b="0"/>
+          </a:lnRef>
+          <a:fillRef idx="0">
+            <a:scrgbClr r="0" g="0" b="0"/>
+          </a:fillRef>
+          <a:effectRef idx="0">
+            <a:scrgbClr r="0" g="0" b="0"/>
+          </a:effectRef>
+          <a:fontRef idx="minor"/>
+        </p:style>
+        <p:txBody>
+          <a:bodyPr lIns="90000" tIns="45000" rIns="90000" bIns="45000" anchor="t">
+            <a:noAutofit/>
+          </a:bodyPr>
+          <a:lstStyle/>
+          <a:p>
+            <a:endParaRPr lang="en-US" sz="1800" b="0" strike="noStrike" spc="-1">
+              <a:solidFill>
+                <a:srgbClr val="FFFFFF"/>
+              </a:solidFill>
+              <a:latin typeface="Arial"/>
+            </a:endParaRPr>
+          </a:p>
+        </p:txBody>
+      </p:sp>
+      <p:sp>
+        <p:nvSpPr>
+          <p:cNvPr id="132" name="Text 6"/>
+          <p:cNvSpPr/>
+          <p:nvPr/>
+        </p:nvSpPr>
+        <p:spPr>
+          <a:xfrm>
+            <a:off x="713160" y="2011680"/>
+            <a:ext cx="4114440" cy="273960"/>
+          </a:xfrm>
+          <a:prstGeom prst="rect">
+            <a:avLst/>
+          </a:prstGeom>
+          <a:noFill/>
+          <a:ln w="0">
+            <a:noFill/>
+          </a:ln>
+        </p:spPr>
+        <p:style>
+          <a:lnRef idx="0">
+            <a:scrgbClr r="0" g="0" b="0"/>
+          </a:lnRef>
+          <a:fillRef idx="0">
+            <a:scrgbClr r="0" g="0" b="0"/>
+          </a:fillRef>
+          <a:effectRef idx="0">
+            <a:scrgbClr r="0" g="0" b="0"/>
+          </a:effectRef>
+          <a:fontRef idx="minor"/>
+        </p:style>
+        <p:txBody>
+          <a:bodyPr lIns="0" tIns="0" rIns="0" bIns="0" anchor="ctr">
+            <a:noAutofit/>
+          </a:bodyPr>
+          <a:lstStyle/>
+          <a:p>
+            <a:pPr defTabSz="914400">
+              <a:lnSpc>
+                <a:spcPct val="100000"/>
+              </a:lnSpc>
+              <a:tabLst>
+                <a:tab pos="0" algn="l"/>
+              </a:tabLst>
+            </a:pPr>
+            <a:r>
+              <a:rPr lang="en-US" sz="1100" b="1" strike="noStrike" spc="-1">
+                <a:solidFill>
+                  <a:srgbClr val="E8A828"/>
+                </a:solidFill>
+                <a:latin typeface="Calibri"/>
+                <a:ea typeface="Calibri"/>
+              </a:rPr>
+              <a:t>OCR Cleanup</a:t>
+            </a:r>
+            <a:endParaRPr lang="en-US" sz="1100" b="0" strike="noStrike" spc="-1">
+              <a:solidFill>
+                <a:srgbClr val="FFFFFF"/>
+              </a:solidFill>
+              <a:latin typeface="Arial"/>
+            </a:endParaRPr>
+          </a:p>
+        </p:txBody>
+      </p:sp>
+      <p:sp>
+        <p:nvSpPr>
+          <p:cNvPr id="133" name="Text 7"/>
+          <p:cNvSpPr/>
+          <p:nvPr/>
+        </p:nvSpPr>
+        <p:spPr>
+          <a:xfrm>
+            <a:off x="713160" y="2267640"/>
+            <a:ext cx="4114440" cy="548280"/>
+          </a:xfrm>
+          <a:prstGeom prst="rect">
+            <a:avLst/>
+          </a:prstGeom>
+          <a:noFill/>
+          <a:ln w="0">
+            <a:noFill/>
+          </a:ln>
+        </p:spPr>
+        <p:style>
+          <a:lnRef idx="0">
+            <a:scrgbClr r="0" g="0" b="0"/>
+          </a:lnRef>
+          <a:fillRef idx="0">
+            <a:scrgbClr r="0" g="0" b="0"/>
+          </a:fillRef>
+          <a:effectRef idx="0">
+            <a:scrgbClr r="0" g="0" b="0"/>
+          </a:effectRef>
+          <a:fontRef idx="minor"/>
+        </p:style>
+        <p:txBody>
+          <a:bodyPr lIns="0" tIns="0" rIns="0" bIns="0" anchor="ctr">
+            <a:noAutofit/>
+          </a:bodyPr>
+          <a:lstStyle/>
+          <a:p>
+            <a:pPr defTabSz="914400">
+              <a:lnSpc>
+                <a:spcPct val="100000"/>
+              </a:lnSpc>
+              <a:tabLst>
+                <a:tab pos="0" algn="l"/>
+              </a:tabLst>
+            </a:pPr>
+            <a:r>
+              <a:rPr lang="en-US" sz="950" b="0" strike="noStrike" spc="-1">
+                <a:solidFill>
+                  <a:srgbClr val="8892A4"/>
+                </a:solidFill>
+                <a:latin typeface="Calibri"/>
+                <a:ea typeface="Calibri"/>
+              </a:rPr>
+              <a:t>~265 garbled English glosses fixed via page-by-page vision-reading of all 476 source pages; fixes propagated to en/hi/dev (June 11–18).</a:t>
+            </a:r>
+            <a:endParaRPr lang="en-US" sz="950" b="0" strike="noStrike" spc="-1">
+              <a:solidFill>
+                <a:srgbClr val="FFFFFF"/>
+              </a:solidFill>
+              <a:latin typeface="Arial"/>
+            </a:endParaRPr>
+          </a:p>
+        </p:txBody>
+      </p:sp>
+      <p:sp>
+        <p:nvSpPr>
+          <p:cNvPr id="134" name="Shape 8"/>
+          <p:cNvSpPr/>
+          <p:nvPr/>
+        </p:nvSpPr>
+        <p:spPr>
+          <a:xfrm>
+            <a:off x="365760" y="3017520"/>
+            <a:ext cx="255600" cy="255600"/>
+          </a:xfrm>
+          <a:prstGeom prst="ellipse">
+            <a:avLst/>
+          </a:prstGeom>
+          <a:solidFill>
+            <a:srgbClr val="C17A2E"/>
+          </a:solidFill>
+          <a:ln w="12700">
+            <a:solidFill>
+              <a:srgbClr val="C17A2E"/>
+            </a:solidFill>
+            <a:round/>
+          </a:ln>
+        </p:spPr>
+        <p:style>
+          <a:lnRef idx="0">
+            <a:scrgbClr r="0" g="0" b="0"/>
+          </a:lnRef>
+          <a:fillRef idx="0">
+            <a:scrgbClr r="0" g="0" b="0"/>
+          </a:fillRef>
+          <a:effectRef idx="0">
+            <a:scrgbClr r="0" g="0" b="0"/>
+          </a:effectRef>
+          <a:fontRef idx="minor"/>
+        </p:style>
+        <p:txBody>
+          <a:bodyPr lIns="90000" tIns="45000" rIns="90000" bIns="45000" anchor="t">
+            <a:noAutofit/>
+          </a:bodyPr>
+          <a:lstStyle/>
+          <a:p>
+            <a:endParaRPr lang="en-US" sz="1800" b="0" strike="noStrike" spc="-1">
+              <a:solidFill>
+                <a:srgbClr val="FFFFFF"/>
+              </a:solidFill>
+              <a:latin typeface="Arial"/>
+            </a:endParaRPr>
+          </a:p>
+        </p:txBody>
+      </p:sp>
+      <p:sp>
+        <p:nvSpPr>
+          <p:cNvPr id="135" name="Text 9"/>
+          <p:cNvSpPr/>
+          <p:nvPr/>
+        </p:nvSpPr>
+        <p:spPr>
+          <a:xfrm>
+            <a:off x="713160" y="2971800"/>
+            <a:ext cx="4114440" cy="273960"/>
+          </a:xfrm>
+          <a:prstGeom prst="rect">
+            <a:avLst/>
+          </a:prstGeom>
+          <a:noFill/>
+          <a:ln w="0">
+            <a:noFill/>
+          </a:ln>
+        </p:spPr>
+        <p:style>
+          <a:lnRef idx="0">
+            <a:scrgbClr r="0" g="0" b="0"/>
+          </a:lnRef>
+          <a:fillRef idx="0">
+            <a:scrgbClr r="0" g="0" b="0"/>
+          </a:fillRef>
+          <a:effectRef idx="0">
+            <a:scrgbClr r="0" g="0" b="0"/>
+          </a:effectRef>
+          <a:fontRef idx="minor"/>
+        </p:style>
+        <p:txBody>
+          <a:bodyPr lIns="0" tIns="0" rIns="0" bIns="0" anchor="ctr">
+            <a:noAutofit/>
+          </a:bodyPr>
+          <a:lstStyle/>
+          <a:p>
+            <a:pPr defTabSz="914400">
+              <a:lnSpc>
+                <a:spcPct val="100000"/>
+              </a:lnSpc>
+              <a:tabLst>
+                <a:tab pos="0" algn="l"/>
+              </a:tabLst>
+            </a:pPr>
+            <a:r>
+              <a:rPr lang="en-US" sz="1100" b="1" strike="noStrike" spc="-1">
+                <a:solidFill>
+                  <a:srgbClr val="E8A828"/>
+                </a:solidFill>
+                <a:latin typeface="Calibri"/>
+                <a:ea typeface="Calibri"/>
+              </a:rPr>
+              <a:t>Book-Alignment Marathon</a:t>
+            </a:r>
+            <a:endParaRPr lang="en-US" sz="1100" b="0" strike="noStrike" spc="-1">
+              <a:solidFill>
+                <a:srgbClr val="FFFFFF"/>
+              </a:solidFill>
+              <a:latin typeface="Arial"/>
+            </a:endParaRPr>
+          </a:p>
+        </p:txBody>
+      </p:sp>
+      <p:sp>
+        <p:nvSpPr>
+          <p:cNvPr id="136" name="Text 10"/>
+          <p:cNvSpPr/>
+          <p:nvPr/>
+        </p:nvSpPr>
+        <p:spPr>
+          <a:xfrm>
+            <a:off x="713160" y="3227760"/>
+            <a:ext cx="4114440" cy="548280"/>
+          </a:xfrm>
+          <a:prstGeom prst="rect">
+            <a:avLst/>
+          </a:prstGeom>
+          <a:noFill/>
+          <a:ln w="0">
+            <a:noFill/>
+          </a:ln>
+        </p:spPr>
+        <p:style>
+          <a:lnRef idx="0">
+            <a:scrgbClr r="0" g="0" b="0"/>
+          </a:lnRef>
+          <a:fillRef idx="0">
+            <a:scrgbClr r="0" g="0" b="0"/>
+          </a:fillRef>
+          <a:effectRef idx="0">
+            <a:scrgbClr r="0" g="0" b="0"/>
+          </a:effectRef>
+          <a:fontRef idx="minor"/>
+        </p:style>
+        <p:txBody>
+          <a:bodyPr lIns="0" tIns="0" rIns="0" bIns="0" anchor="ctr">
+            <a:noAutofit/>
+          </a:bodyPr>
+          <a:lstStyle/>
+          <a:p>
+            <a:pPr defTabSz="914400">
+              <a:lnSpc>
+                <a:spcPct val="100000"/>
+              </a:lnSpc>
+              <a:tabLst>
+                <a:tab pos="0" algn="l"/>
+              </a:tabLst>
+            </a:pPr>
+            <a:r>
+              <a:rPr lang="en-US" sz="950" b="0" strike="noStrike" spc="-1">
+                <a:solidFill>
+                  <a:srgbClr val="8892A4"/>
+                </a:solidFill>
+                <a:latin typeface="Calibri"/>
+                <a:ea typeface="Calibri"/>
+              </a:rPr>
+              <a:t>514+ verse boundary leaks removed; all 18 chapters individually re-verified against the printed book; homorganic nasal transliteration applied (June 18–21).</a:t>
+            </a:r>
+            <a:endParaRPr lang="en-US" sz="950" b="0" strike="noStrike" spc="-1">
+              <a:solidFill>
+                <a:srgbClr val="FFFFFF"/>
+              </a:solidFill>
+              <a:latin typeface="Arial"/>
+            </a:endParaRPr>
+          </a:p>
+        </p:txBody>
+      </p:sp>
+      <p:sp>
+        <p:nvSpPr>
+          <p:cNvPr id="137" name="Shape 11"/>
+          <p:cNvSpPr/>
+          <p:nvPr/>
+        </p:nvSpPr>
+        <p:spPr>
+          <a:xfrm>
+            <a:off x="365760" y="3977640"/>
+            <a:ext cx="255600" cy="255600"/>
+          </a:xfrm>
+          <a:prstGeom prst="ellipse">
+            <a:avLst/>
+          </a:prstGeom>
+          <a:solidFill>
+            <a:srgbClr val="C17A2E"/>
+          </a:solidFill>
+          <a:ln w="12700">
+            <a:solidFill>
+              <a:srgbClr val="C17A2E"/>
+            </a:solidFill>
+            <a:round/>
+          </a:ln>
+        </p:spPr>
+        <p:style>
+          <a:lnRef idx="0">
+            <a:scrgbClr r="0" g="0" b="0"/>
+          </a:lnRef>
+          <a:fillRef idx="0">
+            <a:scrgbClr r="0" g="0" b="0"/>
+          </a:fillRef>
+          <a:effectRef idx="0">
+            <a:scrgbClr r="0" g="0" b="0"/>
+          </a:effectRef>
+          <a:fontRef idx="minor"/>
+        </p:style>
+        <p:txBody>
+          <a:bodyPr lIns="90000" tIns="45000" rIns="90000" bIns="45000" anchor="t">
+            <a:noAutofit/>
+          </a:bodyPr>
+          <a:lstStyle/>
+          <a:p>
+            <a:endParaRPr lang="en-US" sz="1800" b="0" strike="noStrike" spc="-1">
+              <a:solidFill>
+                <a:srgbClr val="FFFFFF"/>
+              </a:solidFill>
+              <a:latin typeface="Arial"/>
+            </a:endParaRPr>
+          </a:p>
+        </p:txBody>
+      </p:sp>
+      <p:sp>
+        <p:nvSpPr>
+          <p:cNvPr id="138" name="Text 12"/>
+          <p:cNvSpPr/>
+          <p:nvPr/>
+        </p:nvSpPr>
+        <p:spPr>
+          <a:xfrm>
+            <a:off x="713160" y="3931920"/>
+            <a:ext cx="4114440" cy="273960"/>
+          </a:xfrm>
+          <a:prstGeom prst="rect">
+            <a:avLst/>
+          </a:prstGeom>
+          <a:noFill/>
+          <a:ln w="0">
+            <a:noFill/>
+          </a:ln>
+        </p:spPr>
+        <p:style>
+          <a:lnRef idx="0">
+            <a:scrgbClr r="0" g="0" b="0"/>
+          </a:lnRef>
+          <a:fillRef idx="0">
+            <a:scrgbClr r="0" g="0" b="0"/>
+          </a:fillRef>
+          <a:effectRef idx="0">
+            <a:scrgbClr r="0" g="0" b="0"/>
+          </a:effectRef>
+          <a:fontRef idx="minor"/>
+        </p:style>
+        <p:txBody>
+          <a:bodyPr lIns="0" tIns="0" rIns="0" bIns="0" anchor="ctr">
+            <a:noAutofit/>
+          </a:bodyPr>
+          <a:lstStyle/>
+          <a:p>
+            <a:pPr defTabSz="914400">
+              <a:lnSpc>
+                <a:spcPct val="100000"/>
+              </a:lnSpc>
+              <a:tabLst>
+                <a:tab pos="0" algn="l"/>
+              </a:tabLst>
+            </a:pPr>
+            <a:r>
+              <a:rPr lang="en-US" sz="1100" b="1" strike="noStrike" spc="-1">
+                <a:solidFill>
+                  <a:srgbClr val="E8A828"/>
+                </a:solidFill>
+                <a:latin typeface="Calibri"/>
+                <a:ea typeface="Calibri"/>
+              </a:rPr>
+              <a:t>Concept Map Filtering</a:t>
+            </a:r>
+            <a:endParaRPr lang="en-US" sz="1100" b="0" strike="noStrike" spc="-1">
+              <a:solidFill>
+                <a:srgbClr val="FFFFFF"/>
+              </a:solidFill>
+              <a:latin typeface="Arial"/>
+            </a:endParaRPr>
+          </a:p>
+        </p:txBody>
+      </p:sp>
+      <p:sp>
+        <p:nvSpPr>
+          <p:cNvPr id="139" name="Text 13"/>
+          <p:cNvSpPr/>
+          <p:nvPr/>
+        </p:nvSpPr>
+        <p:spPr>
+          <a:xfrm>
+            <a:off x="713160" y="4187880"/>
+            <a:ext cx="4114440" cy="548280"/>
+          </a:xfrm>
+          <a:prstGeom prst="rect">
+            <a:avLst/>
+          </a:prstGeom>
+          <a:noFill/>
+          <a:ln w="0">
+            <a:noFill/>
+          </a:ln>
+        </p:spPr>
+        <p:style>
+          <a:lnRef idx="0">
+            <a:scrgbClr r="0" g="0" b="0"/>
+          </a:lnRef>
+          <a:fillRef idx="0">
+            <a:scrgbClr r="0" g="0" b="0"/>
+          </a:fillRef>
+          <a:effectRef idx="0">
+            <a:scrgbClr r="0" g="0" b="0"/>
+          </a:effectRef>
+          <a:fontRef idx="minor"/>
+        </p:style>
+        <p:txBody>
+          <a:bodyPr lIns="0" tIns="0" rIns="0" bIns="0" anchor="ctr">
+            <a:noAutofit/>
+          </a:bodyPr>
+          <a:lstStyle/>
+          <a:p>
+            <a:pPr defTabSz="914400">
+              <a:lnSpc>
+                <a:spcPct val="100000"/>
+              </a:lnSpc>
+              <a:tabLst>
+                <a:tab pos="0" algn="l"/>
+              </a:tabLst>
+            </a:pPr>
+            <a:r>
+              <a:rPr lang="en-US" sz="950" b="0" strike="noStrike" spc="-1">
+                <a:solidFill>
+                  <a:srgbClr val="8892A4"/>
+                </a:solidFill>
+                <a:latin typeface="Calibri"/>
+                <a:ea typeface="Calibri"/>
+              </a:rPr>
+              <a:t>New Adhyaya (chapter) and Shloka dropdowns filter the Map to one chapter or verse, auto-centering on the relevant concepts.</a:t>
+            </a:r>
+            <a:endParaRPr lang="en-US" sz="950" b="0" strike="noStrike" spc="-1">
+              <a:solidFill>
+                <a:srgbClr val="FFFFFF"/>
+              </a:solidFill>
+              <a:latin typeface="Arial"/>
+            </a:endParaRPr>
+          </a:p>
+        </p:txBody>
+      </p:sp>
+      <p:sp>
+        <p:nvSpPr>
+          <p:cNvPr id="140" name="Shape 14"/>
+          <p:cNvSpPr/>
+          <p:nvPr/>
+        </p:nvSpPr>
+        <p:spPr>
+          <a:xfrm flipH="1">
+            <a:off x="6035040" y="1417320"/>
+            <a:ext cx="914400" cy="868680"/>
+          </a:xfrm>
+          <a:prstGeom prst="line">
+            <a:avLst/>
+          </a:prstGeom>
+          <a:ln w="10160">
+            <a:solidFill>
+              <a:srgbClr val="8892A4"/>
+            </a:solidFill>
+            <a:round/>
+          </a:ln>
+        </p:spPr>
+        <p:style>
+          <a:lnRef idx="0">
+            <a:scrgbClr r="0" g="0" b="0"/>
+          </a:lnRef>
+          <a:fillRef idx="0">
+            <a:scrgbClr r="0" g="0" b="0"/>
+          </a:fillRef>
+          <a:effectRef idx="0">
+            <a:scrgbClr r="0" g="0" b="0"/>
+          </a:effectRef>
+          <a:fontRef idx="minor"/>
+        </p:style>
+        <p:txBody>
+          <a:bodyPr lIns="90000" tIns="45000" rIns="90000" bIns="45000" anchor="t" anchorCtr="1">
+            <a:noAutofit/>
+          </a:bodyPr>
+          <a:lstStyle/>
+          <a:p>
+            <a:endParaRPr lang="en-US" sz="1800" b="0" strike="noStrike" spc="-1">
+              <a:solidFill>
+                <a:srgbClr val="FFFFFF"/>
+              </a:solidFill>
+              <a:latin typeface="Arial"/>
+            </a:endParaRPr>
+          </a:p>
+        </p:txBody>
+      </p:sp>
+      <p:sp>
+        <p:nvSpPr>
+          <p:cNvPr id="141" name="Shape 15"/>
+          <p:cNvSpPr/>
+          <p:nvPr/>
+        </p:nvSpPr>
+        <p:spPr>
+          <a:xfrm>
+            <a:off x="6949440" y="1417320"/>
+            <a:ext cx="914400" cy="868680"/>
+          </a:xfrm>
+          <a:prstGeom prst="line">
+            <a:avLst/>
+          </a:prstGeom>
+          <a:ln w="10160">
+            <a:solidFill>
+              <a:srgbClr val="8892A4"/>
+            </a:solidFill>
+            <a:round/>
+          </a:ln>
+        </p:spPr>
+        <p:style>
+          <a:lnRef idx="0">
+            <a:scrgbClr r="0" g="0" b="0"/>
+          </a:lnRef>
+          <a:fillRef idx="0">
+            <a:scrgbClr r="0" g="0" b="0"/>
+          </a:fillRef>
+          <a:effectRef idx="0">
+            <a:scrgbClr r="0" g="0" b="0"/>
+          </a:effectRef>
+          <a:fontRef idx="minor"/>
+        </p:style>
+        <p:txBody>
+          <a:bodyPr lIns="90000" tIns="45000" rIns="90000" bIns="45000" anchor="t" anchorCtr="1">
+            <a:noAutofit/>
+          </a:bodyPr>
+          <a:lstStyle/>
+          <a:p>
+            <a:endParaRPr lang="en-US" sz="1800" b="0" strike="noStrike" spc="-1">
+              <a:solidFill>
+                <a:srgbClr val="FFFFFF"/>
+              </a:solidFill>
+              <a:latin typeface="Arial"/>
+            </a:endParaRPr>
+          </a:p>
+        </p:txBody>
+      </p:sp>
+      <p:sp>
+        <p:nvSpPr>
+          <p:cNvPr id="142" name="Shape 16"/>
+          <p:cNvSpPr/>
+          <p:nvPr/>
+        </p:nvSpPr>
+        <p:spPr>
+          <a:xfrm flipH="1">
+            <a:off x="5760720" y="2286000"/>
+            <a:ext cx="274320" cy="868680"/>
+          </a:xfrm>
+          <a:prstGeom prst="line">
+            <a:avLst/>
+          </a:prstGeom>
+          <a:ln w="10160">
+            <a:solidFill>
+              <a:srgbClr val="8892A4"/>
+            </a:solidFill>
+            <a:round/>
+          </a:ln>
+        </p:spPr>
+        <p:style>
+          <a:lnRef idx="0">
+            <a:scrgbClr r="0" g="0" b="0"/>
+          </a:lnRef>
+          <a:fillRef idx="0">
+            <a:scrgbClr r="0" g="0" b="0"/>
+          </a:fillRef>
+          <a:effectRef idx="0">
+            <a:scrgbClr r="0" g="0" b="0"/>
+          </a:effectRef>
+          <a:fontRef idx="minor"/>
+        </p:style>
+        <p:txBody>
+          <a:bodyPr lIns="90000" tIns="45000" rIns="90000" bIns="45000" anchor="t" anchorCtr="1">
+            <a:noAutofit/>
+          </a:bodyPr>
+          <a:lstStyle/>
+          <a:p>
+            <a:endParaRPr lang="en-US" sz="1800" b="0" strike="noStrike" spc="-1">
+              <a:solidFill>
+                <a:srgbClr val="FFFFFF"/>
+              </a:solidFill>
+              <a:latin typeface="Arial"/>
+            </a:endParaRPr>
+          </a:p>
+        </p:txBody>
+      </p:sp>
+      <p:sp>
+        <p:nvSpPr>
+          <p:cNvPr id="143" name="Shape 17"/>
+          <p:cNvSpPr/>
+          <p:nvPr/>
+        </p:nvSpPr>
+        <p:spPr>
+          <a:xfrm flipH="1">
+            <a:off x="7223760" y="2286000"/>
+            <a:ext cx="640080" cy="1051560"/>
+          </a:xfrm>
+          <a:prstGeom prst="line">
+            <a:avLst/>
+          </a:prstGeom>
+          <a:ln w="10160">
+            <a:solidFill>
+              <a:srgbClr val="8892A4"/>
+            </a:solidFill>
+            <a:round/>
+          </a:ln>
+        </p:spPr>
+        <p:style>
+          <a:lnRef idx="0">
+            <a:scrgbClr r="0" g="0" b="0"/>
+          </a:lnRef>
+          <a:fillRef idx="0">
+            <a:scrgbClr r="0" g="0" b="0"/>
+          </a:fillRef>
+          <a:effectRef idx="0">
+            <a:scrgbClr r="0" g="0" b="0"/>
+          </a:effectRef>
+          <a:fontRef idx="minor"/>
+        </p:style>
+        <p:txBody>
+          <a:bodyPr lIns="90000" tIns="45000" rIns="90000" bIns="45000" anchor="t" anchorCtr="1">
+            <a:noAutofit/>
+          </a:bodyPr>
+          <a:lstStyle/>
+          <a:p>
+            <a:endParaRPr lang="en-US" sz="1800" b="0" strike="noStrike" spc="-1">
+              <a:solidFill>
+                <a:srgbClr val="FFFFFF"/>
+              </a:solidFill>
+              <a:latin typeface="Arial"/>
+            </a:endParaRPr>
+          </a:p>
+        </p:txBody>
+      </p:sp>
+      <p:sp>
+        <p:nvSpPr>
+          <p:cNvPr id="144" name="Shape 18"/>
+          <p:cNvSpPr/>
+          <p:nvPr/>
+        </p:nvSpPr>
+        <p:spPr>
+          <a:xfrm>
+            <a:off x="7863840" y="2286000"/>
+            <a:ext cx="457200" cy="868680"/>
+          </a:xfrm>
+          <a:prstGeom prst="line">
+            <a:avLst/>
+          </a:prstGeom>
+          <a:ln w="10160">
+            <a:solidFill>
+              <a:srgbClr val="8892A4"/>
+            </a:solidFill>
+            <a:round/>
+          </a:ln>
+        </p:spPr>
+        <p:style>
+          <a:lnRef idx="0">
+            <a:scrgbClr r="0" g="0" b="0"/>
+          </a:lnRef>
+          <a:fillRef idx="0">
+            <a:scrgbClr r="0" g="0" b="0"/>
+          </a:fillRef>
+          <a:effectRef idx="0">
+            <a:scrgbClr r="0" g="0" b="0"/>
+          </a:effectRef>
+          <a:fontRef idx="minor"/>
+        </p:style>
+        <p:txBody>
+          <a:bodyPr lIns="90000" tIns="45000" rIns="90000" bIns="45000" anchor="t" anchorCtr="1">
+            <a:noAutofit/>
+          </a:bodyPr>
+          <a:lstStyle/>
+          <a:p>
+            <a:endParaRPr lang="en-US" sz="1800" b="0" strike="noStrike" spc="-1">
+              <a:solidFill>
+                <a:srgbClr val="FFFFFF"/>
+              </a:solidFill>
+              <a:latin typeface="Arial"/>
+            </a:endParaRPr>
+          </a:p>
+        </p:txBody>
+      </p:sp>
+      <p:sp>
+        <p:nvSpPr>
+          <p:cNvPr id="145" name="Shape 19"/>
+          <p:cNvSpPr/>
+          <p:nvPr/>
+        </p:nvSpPr>
+        <p:spPr>
+          <a:xfrm>
+            <a:off x="6035040" y="2286000"/>
+            <a:ext cx="1828800" cy="360"/>
+          </a:xfrm>
+          <a:prstGeom prst="line">
+            <a:avLst/>
+          </a:prstGeom>
+          <a:ln w="10160">
+            <a:solidFill>
+              <a:srgbClr val="8892A4"/>
+            </a:solidFill>
+            <a:round/>
+          </a:ln>
+        </p:spPr>
+        <p:style>
+          <a:lnRef idx="0">
+            <a:scrgbClr r="0" g="0" b="0"/>
+          </a:lnRef>
+          <a:fillRef idx="0">
+            <a:scrgbClr r="0" g="0" b="0"/>
+          </a:fillRef>
+          <a:effectRef idx="0">
+            <a:scrgbClr r="0" g="0" b="0"/>
+          </a:effectRef>
+          <a:fontRef idx="minor"/>
+        </p:style>
+        <p:txBody>
+          <a:bodyPr lIns="90000" tIns="-44640" rIns="90000" bIns="-44640" anchor="t" anchorCtr="1">
+            <a:noAutofit/>
+          </a:bodyPr>
+          <a:lstStyle/>
+          <a:p>
+            <a:endParaRPr lang="en-US" sz="1800" b="0" strike="noStrike" spc="-1">
+              <a:solidFill>
+                <a:srgbClr val="FFFFFF"/>
+              </a:solidFill>
+              <a:latin typeface="Arial"/>
+            </a:endParaRPr>
+          </a:p>
+        </p:txBody>
+      </p:sp>
+      <p:sp>
+        <p:nvSpPr>
+          <p:cNvPr id="146" name="Shape 20"/>
+          <p:cNvSpPr/>
+          <p:nvPr/>
+        </p:nvSpPr>
+        <p:spPr>
+          <a:xfrm>
+            <a:off x="6510600" y="1188720"/>
+            <a:ext cx="694440" cy="694440"/>
+          </a:xfrm>
+          <a:prstGeom prst="ellipse">
+            <a:avLst/>
+          </a:prstGeom>
+          <a:solidFill>
+            <a:srgbClr val="E8A828"/>
+          </a:solidFill>
+          <a:ln w="6350">
+            <a:solidFill>
+              <a:srgbClr val="FFFFFF"/>
+            </a:solidFill>
+            <a:round/>
+          </a:ln>
+        </p:spPr>
+        <p:style>
+          <a:lnRef idx="0">
+            <a:scrgbClr r="0" g="0" b="0"/>
+          </a:lnRef>
+          <a:fillRef idx="0">
+            <a:scrgbClr r="0" g="0" b="0"/>
+          </a:fillRef>
+          <a:effectRef idx="0">
+            <a:scrgbClr r="0" g="0" b="0"/>
+          </a:effectRef>
+          <a:fontRef idx="minor"/>
+        </p:style>
+        <p:txBody>
+          <a:bodyPr lIns="90000" tIns="45000" rIns="90000" bIns="45000" anchor="t">
+            <a:noAutofit/>
+          </a:bodyPr>
+          <a:lstStyle/>
+          <a:p>
+            <a:endParaRPr lang="en-US" sz="1800" b="0" strike="noStrike" spc="-1">
+              <a:solidFill>
+                <a:srgbClr val="000000"/>
+              </a:solidFill>
+              <a:latin typeface="Arial"/>
+            </a:endParaRPr>
+          </a:p>
+        </p:txBody>
+      </p:sp>
+      <p:sp>
+        <p:nvSpPr>
+          <p:cNvPr id="147" name="Text 21"/>
+          <p:cNvSpPr/>
+          <p:nvPr/>
+        </p:nvSpPr>
+        <p:spPr>
+          <a:xfrm>
+            <a:off x="6217920" y="1901880"/>
+            <a:ext cx="1279800" cy="228240"/>
+          </a:xfrm>
+          <a:prstGeom prst="rect">
+            <a:avLst/>
+          </a:prstGeom>
+          <a:noFill/>
+          <a:ln w="0">
+            <a:noFill/>
+          </a:ln>
+        </p:spPr>
+        <p:style>
+          <a:lnRef idx="0">
+            <a:scrgbClr r="0" g="0" b="0"/>
+          </a:lnRef>
+          <a:fillRef idx="0">
+            <a:scrgbClr r="0" g="0" b="0"/>
+          </a:fillRef>
+          <a:effectRef idx="0">
+            <a:scrgbClr r="0" g="0" b="0"/>
+          </a:effectRef>
+          <a:fontRef idx="minor"/>
+        </p:style>
+        <p:txBody>
+          <a:bodyPr lIns="90000" tIns="45000" rIns="90000" bIns="45000" anchor="ctr">
+            <a:noAutofit/>
+          </a:bodyPr>
+          <a:lstStyle/>
+          <a:p>
+            <a:pPr algn="ctr" defTabSz="914400">
+              <a:lnSpc>
+                <a:spcPct val="100000"/>
+              </a:lnSpc>
+              <a:tabLst>
+                <a:tab pos="0" algn="l"/>
+              </a:tabLst>
+            </a:pPr>
+            <a:r>
+              <a:rPr lang="en-US" sz="750" b="0" strike="noStrike" spc="-1">
+                <a:solidFill>
+                  <a:srgbClr val="8892A4"/>
+                </a:solidFill>
+                <a:latin typeface="Calibri"/>
+              </a:rPr>
+              <a:t>514+ leaks fixed</a:t>
+            </a:r>
+            <a:endParaRPr lang="en-US" sz="750" b="0" strike="noStrike" spc="-1">
+              <a:solidFill>
+                <a:srgbClr val="FFFFFF"/>
+              </a:solidFill>
+              <a:latin typeface="Arial"/>
+            </a:endParaRPr>
+          </a:p>
+        </p:txBody>
+      </p:sp>
+      <p:sp>
+        <p:nvSpPr>
+          <p:cNvPr id="148" name="Shape 22"/>
+          <p:cNvSpPr/>
+          <p:nvPr/>
+        </p:nvSpPr>
+        <p:spPr>
+          <a:xfrm>
+            <a:off x="5687640" y="2057400"/>
+            <a:ext cx="511560" cy="511560"/>
+          </a:xfrm>
+          <a:prstGeom prst="ellipse">
+            <a:avLst/>
+          </a:prstGeom>
+          <a:solidFill>
+            <a:srgbClr val="C17A2E"/>
+          </a:solidFill>
+          <a:ln w="6350">
+            <a:solidFill>
+              <a:srgbClr val="FFFFFF"/>
+            </a:solidFill>
+            <a:round/>
+          </a:ln>
+        </p:spPr>
+        <p:style>
+          <a:lnRef idx="0">
+            <a:scrgbClr r="0" g="0" b="0"/>
+          </a:lnRef>
+          <a:fillRef idx="0">
+            <a:scrgbClr r="0" g="0" b="0"/>
+          </a:fillRef>
+          <a:effectRef idx="0">
+            <a:scrgbClr r="0" g="0" b="0"/>
+          </a:effectRef>
+          <a:fontRef idx="minor"/>
+        </p:style>
+        <p:txBody>
+          <a:bodyPr lIns="90000" tIns="45000" rIns="90000" bIns="45000" anchor="t">
+            <a:noAutofit/>
+          </a:bodyPr>
+          <a:lstStyle/>
+          <a:p>
+            <a:endParaRPr lang="en-US" sz="1800" b="0" strike="noStrike" spc="-1">
+              <a:solidFill>
+                <a:srgbClr val="FFFFFF"/>
+              </a:solidFill>
+              <a:latin typeface="Arial"/>
+            </a:endParaRPr>
+          </a:p>
+        </p:txBody>
+      </p:sp>
+      <p:sp>
+        <p:nvSpPr>
+          <p:cNvPr id="149" name="Text 23"/>
+          <p:cNvSpPr/>
+          <p:nvPr/>
+        </p:nvSpPr>
+        <p:spPr>
+          <a:xfrm>
+            <a:off x="5303520" y="2587680"/>
+            <a:ext cx="1279800" cy="228240"/>
+          </a:xfrm>
+          <a:prstGeom prst="rect">
+            <a:avLst/>
+          </a:prstGeom>
+          <a:noFill/>
+          <a:ln w="0">
+            <a:noFill/>
+          </a:ln>
+        </p:spPr>
+        <p:style>
+          <a:lnRef idx="0">
+            <a:scrgbClr r="0" g="0" b="0"/>
+          </a:lnRef>
+          <a:fillRef idx="0">
+            <a:scrgbClr r="0" g="0" b="0"/>
+          </a:fillRef>
+          <a:effectRef idx="0">
+            <a:scrgbClr r="0" g="0" b="0"/>
+          </a:effectRef>
+          <a:fontRef idx="minor"/>
+        </p:style>
+        <p:txBody>
+          <a:bodyPr lIns="90000" tIns="45000" rIns="90000" bIns="45000" anchor="ctr">
+            <a:noAutofit/>
+          </a:bodyPr>
+          <a:lstStyle/>
+          <a:p>
+            <a:pPr algn="ctr" defTabSz="914400">
+              <a:lnSpc>
+                <a:spcPct val="100000"/>
+              </a:lnSpc>
+              <a:tabLst>
+                <a:tab pos="0" algn="l"/>
+              </a:tabLst>
+            </a:pPr>
+            <a:r>
+              <a:rPr lang="en-US" sz="750" b="0" strike="noStrike" spc="-1">
+                <a:solidFill>
+                  <a:srgbClr val="8892A4"/>
+                </a:solidFill>
+                <a:latin typeface="Calibri"/>
+              </a:rPr>
+              <a:t>476 pages</a:t>
+            </a:r>
+            <a:endParaRPr lang="en-US" sz="750" b="0" strike="noStrike" spc="-1">
+              <a:solidFill>
+                <a:srgbClr val="FFFFFF"/>
+              </a:solidFill>
+              <a:latin typeface="Arial"/>
+            </a:endParaRPr>
+          </a:p>
+        </p:txBody>
+      </p:sp>
+      <p:sp>
+        <p:nvSpPr>
+          <p:cNvPr id="150" name="Shape 24"/>
+          <p:cNvSpPr/>
+          <p:nvPr/>
+        </p:nvSpPr>
+        <p:spPr>
+          <a:xfrm>
+            <a:off x="7516440" y="2057400"/>
+            <a:ext cx="511560" cy="511560"/>
+          </a:xfrm>
+          <a:prstGeom prst="ellipse">
+            <a:avLst/>
+          </a:prstGeom>
+          <a:solidFill>
+            <a:srgbClr val="4A7C59"/>
+          </a:solidFill>
+          <a:ln w="6350">
+            <a:solidFill>
+              <a:srgbClr val="FFFFFF"/>
+            </a:solidFill>
+            <a:round/>
+          </a:ln>
+        </p:spPr>
+        <p:style>
+          <a:lnRef idx="0">
+            <a:scrgbClr r="0" g="0" b="0"/>
+          </a:lnRef>
+          <a:fillRef idx="0">
+            <a:scrgbClr r="0" g="0" b="0"/>
+          </a:fillRef>
+          <a:effectRef idx="0">
+            <a:scrgbClr r="0" g="0" b="0"/>
+          </a:effectRef>
+          <a:fontRef idx="minor"/>
+        </p:style>
+        <p:txBody>
+          <a:bodyPr lIns="90000" tIns="45000" rIns="90000" bIns="45000" anchor="t">
+            <a:noAutofit/>
+          </a:bodyPr>
+          <a:lstStyle/>
+          <a:p>
+            <a:endParaRPr lang="en-US" sz="1800" b="0" strike="noStrike" spc="-1">
+              <a:solidFill>
+                <a:srgbClr val="FFFFFF"/>
+              </a:solidFill>
+              <a:latin typeface="Arial"/>
+            </a:endParaRPr>
+          </a:p>
+        </p:txBody>
+      </p:sp>
+      <p:sp>
+        <p:nvSpPr>
+          <p:cNvPr id="151" name="Text 25"/>
+          <p:cNvSpPr/>
+          <p:nvPr/>
+        </p:nvSpPr>
+        <p:spPr>
+          <a:xfrm>
+            <a:off x="7132320" y="2587680"/>
+            <a:ext cx="1279800" cy="228240"/>
+          </a:xfrm>
+          <a:prstGeom prst="rect">
+            <a:avLst/>
+          </a:prstGeom>
+          <a:noFill/>
+          <a:ln w="0">
+            <a:noFill/>
+          </a:ln>
+        </p:spPr>
+        <p:style>
+          <a:lnRef idx="0">
+            <a:scrgbClr r="0" g="0" b="0"/>
+          </a:lnRef>
+          <a:fillRef idx="0">
+            <a:scrgbClr r="0" g="0" b="0"/>
+          </a:fillRef>
+          <a:effectRef idx="0">
+            <a:scrgbClr r="0" g="0" b="0"/>
+          </a:effectRef>
+          <a:fontRef idx="minor"/>
+        </p:style>
+        <p:txBody>
+          <a:bodyPr lIns="90000" tIns="45000" rIns="90000" bIns="45000" anchor="ctr">
+            <a:noAutofit/>
+          </a:bodyPr>
+          <a:lstStyle/>
+          <a:p>
+            <a:pPr algn="ctr" defTabSz="914400">
+              <a:lnSpc>
+                <a:spcPct val="100000"/>
+              </a:lnSpc>
+              <a:tabLst>
+                <a:tab pos="0" algn="l"/>
+              </a:tabLst>
+            </a:pPr>
+            <a:r>
+              <a:rPr lang="en-US" sz="750" b="0" strike="noStrike" spc="-1">
+                <a:solidFill>
+                  <a:srgbClr val="8892A4"/>
+                </a:solidFill>
+                <a:latin typeface="Calibri"/>
+              </a:rPr>
+              <a:t>265 garbles</a:t>
+            </a:r>
+            <a:endParaRPr lang="en-US" sz="750" b="0" strike="noStrike" spc="-1">
+              <a:solidFill>
+                <a:srgbClr val="FFFFFF"/>
+              </a:solidFill>
+              <a:latin typeface="Arial"/>
+            </a:endParaRPr>
+          </a:p>
+        </p:txBody>
+      </p:sp>
+      <p:sp>
+        <p:nvSpPr>
+          <p:cNvPr id="152" name="Shape 26"/>
+          <p:cNvSpPr/>
+          <p:nvPr/>
+        </p:nvSpPr>
+        <p:spPr>
+          <a:xfrm>
+            <a:off x="5459040" y="2926080"/>
+            <a:ext cx="420120" cy="420120"/>
+          </a:xfrm>
+          <a:prstGeom prst="ellipse">
+            <a:avLst/>
+          </a:prstGeom>
+          <a:solidFill>
+            <a:srgbClr val="2C3F6E"/>
+          </a:solidFill>
+          <a:ln w="6350">
+            <a:solidFill>
+              <a:srgbClr val="FFFFFF"/>
+            </a:solidFill>
+            <a:round/>
+          </a:ln>
+        </p:spPr>
+        <p:style>
+          <a:lnRef idx="0">
+            <a:scrgbClr r="0" g="0" b="0"/>
+          </a:lnRef>
+          <a:fillRef idx="0">
+            <a:scrgbClr r="0" g="0" b="0"/>
+          </a:fillRef>
+          <a:effectRef idx="0">
+            <a:scrgbClr r="0" g="0" b="0"/>
+          </a:effectRef>
+          <a:fontRef idx="minor"/>
+        </p:style>
+        <p:txBody>
+          <a:bodyPr lIns="90000" tIns="45000" rIns="90000" bIns="45000" anchor="t">
+            <a:noAutofit/>
+          </a:bodyPr>
+          <a:lstStyle/>
+          <a:p>
+            <a:endParaRPr lang="en-US" sz="1800" b="0" strike="noStrike" spc="-1">
+              <a:solidFill>
+                <a:srgbClr val="FFFFFF"/>
+              </a:solidFill>
+              <a:latin typeface="Arial"/>
+            </a:endParaRPr>
+          </a:p>
+        </p:txBody>
+      </p:sp>
+      <p:sp>
+        <p:nvSpPr>
+          <p:cNvPr id="153" name="Text 27"/>
+          <p:cNvSpPr/>
+          <p:nvPr/>
+        </p:nvSpPr>
+        <p:spPr>
+          <a:xfrm>
+            <a:off x="5029200" y="3364920"/>
+            <a:ext cx="1279800" cy="228240"/>
+          </a:xfrm>
+          <a:prstGeom prst="rect">
+            <a:avLst/>
+          </a:prstGeom>
+          <a:noFill/>
+          <a:ln w="0">
+            <a:noFill/>
+          </a:ln>
+        </p:spPr>
+        <p:style>
+          <a:lnRef idx="0">
+            <a:scrgbClr r="0" g="0" b="0"/>
+          </a:lnRef>
+          <a:fillRef idx="0">
+            <a:scrgbClr r="0" g="0" b="0"/>
+          </a:fillRef>
+          <a:effectRef idx="0">
+            <a:scrgbClr r="0" g="0" b="0"/>
+          </a:effectRef>
+          <a:fontRef idx="minor"/>
+        </p:style>
+        <p:txBody>
+          <a:bodyPr lIns="90000" tIns="45000" rIns="90000" bIns="45000" anchor="ctr">
+            <a:noAutofit/>
+          </a:bodyPr>
+          <a:lstStyle/>
+          <a:p>
+            <a:pPr algn="ctr" defTabSz="914400">
+              <a:lnSpc>
+                <a:spcPct val="100000"/>
+              </a:lnSpc>
+              <a:tabLst>
+                <a:tab pos="0" algn="l"/>
+              </a:tabLst>
+            </a:pPr>
+            <a:r>
+              <a:rPr lang="en-US" sz="750" b="0" strike="noStrike" spc="-1">
+                <a:solidFill>
+                  <a:srgbClr val="8892A4"/>
+                </a:solidFill>
+                <a:latin typeface="Calibri"/>
+              </a:rPr>
+              <a:t>18 chapters</a:t>
+            </a:r>
+            <a:endParaRPr lang="en-US" sz="750" b="0" strike="noStrike" spc="-1">
+              <a:solidFill>
+                <a:srgbClr val="FFFFFF"/>
+              </a:solidFill>
+              <a:latin typeface="Arial"/>
+            </a:endParaRPr>
+          </a:p>
+        </p:txBody>
+      </p:sp>
+      <p:sp>
+        <p:nvSpPr>
+          <p:cNvPr id="154" name="Shape 28"/>
+          <p:cNvSpPr/>
+          <p:nvPr/>
+        </p:nvSpPr>
+        <p:spPr>
+          <a:xfrm>
+            <a:off x="6903720" y="3108960"/>
+            <a:ext cx="456840" cy="456840"/>
+          </a:xfrm>
+          <a:prstGeom prst="ellipse">
+            <a:avLst/>
+          </a:prstGeom>
+          <a:solidFill>
+            <a:srgbClr val="2C3F6E"/>
+          </a:solidFill>
+          <a:ln w="6350">
+            <a:solidFill>
+              <a:srgbClr val="FFFFFF"/>
+            </a:solidFill>
+            <a:round/>
+          </a:ln>
+        </p:spPr>
+        <p:style>
+          <a:lnRef idx="0">
+            <a:scrgbClr r="0" g="0" b="0"/>
+          </a:lnRef>
+          <a:fillRef idx="0">
+            <a:scrgbClr r="0" g="0" b="0"/>
+          </a:fillRef>
+          <a:effectRef idx="0">
+            <a:scrgbClr r="0" g="0" b="0"/>
+          </a:effectRef>
+          <a:fontRef idx="minor"/>
+        </p:style>
+        <p:txBody>
+          <a:bodyPr lIns="90000" tIns="45000" rIns="90000" bIns="45000" anchor="t">
+            <a:noAutofit/>
+          </a:bodyPr>
+          <a:lstStyle/>
+          <a:p>
+            <a:endParaRPr lang="en-US" sz="1800" b="0" strike="noStrike" spc="-1">
+              <a:solidFill>
+                <a:srgbClr val="FFFFFF"/>
+              </a:solidFill>
+              <a:latin typeface="Arial"/>
+            </a:endParaRPr>
+          </a:p>
+        </p:txBody>
+      </p:sp>
+      <p:sp>
+        <p:nvSpPr>
+          <p:cNvPr id="155" name="Text 29"/>
+          <p:cNvSpPr/>
+          <p:nvPr/>
+        </p:nvSpPr>
+        <p:spPr>
+          <a:xfrm>
+            <a:off x="6492240" y="3584520"/>
+            <a:ext cx="1279800" cy="228240"/>
+          </a:xfrm>
+          <a:prstGeom prst="rect">
+            <a:avLst/>
+          </a:prstGeom>
+          <a:noFill/>
+          <a:ln w="0">
+            <a:noFill/>
+          </a:ln>
+        </p:spPr>
+        <p:style>
+          <a:lnRef idx="0">
+            <a:scrgbClr r="0" g="0" b="0"/>
+          </a:lnRef>
+          <a:fillRef idx="0">
+            <a:scrgbClr r="0" g="0" b="0"/>
+          </a:fillRef>
+          <a:effectRef idx="0">
+            <a:scrgbClr r="0" g="0" b="0"/>
+          </a:effectRef>
+          <a:fontRef idx="minor"/>
+        </p:style>
+        <p:txBody>
+          <a:bodyPr lIns="90000" tIns="45000" rIns="90000" bIns="45000" anchor="ctr">
+            <a:noAutofit/>
+          </a:bodyPr>
+          <a:lstStyle/>
+          <a:p>
+            <a:pPr algn="ctr" defTabSz="914400">
+              <a:lnSpc>
+                <a:spcPct val="100000"/>
+              </a:lnSpc>
+              <a:tabLst>
+                <a:tab pos="0" algn="l"/>
+              </a:tabLst>
+            </a:pPr>
+            <a:r>
+              <a:rPr lang="en-US" sz="750" b="0" strike="noStrike" spc="-1">
+                <a:solidFill>
+                  <a:srgbClr val="8892A4"/>
+                </a:solidFill>
+                <a:latin typeface="Calibri"/>
+              </a:rPr>
+              <a:t>39+ nodes</a:t>
+            </a:r>
+            <a:endParaRPr lang="en-US" sz="750" b="0" strike="noStrike" spc="-1">
+              <a:solidFill>
+                <a:srgbClr val="FFFFFF"/>
+              </a:solidFill>
+              <a:latin typeface="Arial"/>
+            </a:endParaRPr>
+          </a:p>
+        </p:txBody>
+      </p:sp>
+      <p:sp>
+        <p:nvSpPr>
+          <p:cNvPr id="156" name="Shape 30"/>
+          <p:cNvSpPr/>
+          <p:nvPr/>
+        </p:nvSpPr>
+        <p:spPr>
+          <a:xfrm>
+            <a:off x="8019360" y="2926080"/>
+            <a:ext cx="420120" cy="420120"/>
+          </a:xfrm>
+          <a:prstGeom prst="ellipse">
+            <a:avLst/>
+          </a:prstGeom>
+          <a:solidFill>
+            <a:srgbClr val="9B3A1A"/>
+          </a:solidFill>
+          <a:ln w="6350">
+            <a:solidFill>
+              <a:srgbClr val="FFFFFF"/>
+            </a:solidFill>
+            <a:round/>
+          </a:ln>
+        </p:spPr>
+        <p:style>
+          <a:lnRef idx="0">
+            <a:scrgbClr r="0" g="0" b="0"/>
+          </a:lnRef>
+          <a:fillRef idx="0">
+            <a:scrgbClr r="0" g="0" b="0"/>
+          </a:fillRef>
+          <a:effectRef idx="0">
+            <a:scrgbClr r="0" g="0" b="0"/>
+          </a:effectRef>
+          <a:fontRef idx="minor"/>
+        </p:style>
+        <p:txBody>
+          <a:bodyPr lIns="90000" tIns="45000" rIns="90000" bIns="45000" anchor="t">
+            <a:noAutofit/>
+          </a:bodyPr>
+          <a:lstStyle/>
+          <a:p>
+            <a:endParaRPr lang="en-US" sz="1800" b="0" strike="noStrike" spc="-1">
+              <a:solidFill>
+                <a:srgbClr val="FFFFFF"/>
+              </a:solidFill>
+              <a:latin typeface="Arial"/>
+            </a:endParaRPr>
+          </a:p>
+        </p:txBody>
+      </p:sp>
+      <p:sp>
+        <p:nvSpPr>
+          <p:cNvPr id="157" name="Text 31"/>
+          <p:cNvSpPr/>
+          <p:nvPr/>
+        </p:nvSpPr>
+        <p:spPr>
+          <a:xfrm>
+            <a:off x="7589520" y="3364920"/>
+            <a:ext cx="1279800" cy="228240"/>
+          </a:xfrm>
+          <a:prstGeom prst="rect">
+            <a:avLst/>
+          </a:prstGeom>
+          <a:noFill/>
+          <a:ln w="0">
+            <a:noFill/>
+          </a:ln>
+        </p:spPr>
+        <p:style>
+          <a:lnRef idx="0">
+            <a:scrgbClr r="0" g="0" b="0"/>
+          </a:lnRef>
+          <a:fillRef idx="0">
+            <a:scrgbClr r="0" g="0" b="0"/>
+          </a:fillRef>
+          <a:effectRef idx="0">
+            <a:scrgbClr r="0" g="0" b="0"/>
+          </a:effectRef>
+          <a:fontRef idx="minor"/>
+        </p:style>
+        <p:txBody>
+          <a:bodyPr lIns="90000" tIns="45000" rIns="90000" bIns="45000" anchor="ctr">
+            <a:noAutofit/>
+          </a:bodyPr>
+          <a:lstStyle/>
+          <a:p>
+            <a:pPr algn="ctr" defTabSz="914400">
+              <a:lnSpc>
+                <a:spcPct val="100000"/>
+              </a:lnSpc>
+              <a:tabLst>
+                <a:tab pos="0" algn="l"/>
+              </a:tabLst>
+            </a:pPr>
+            <a:r>
+              <a:rPr lang="en-US" sz="750" b="0" strike="noStrike" spc="-1">
+                <a:solidFill>
+                  <a:srgbClr val="8892A4"/>
+                </a:solidFill>
+                <a:latin typeface="Calibri"/>
+              </a:rPr>
+              <a:t>701 shlokas</a:t>
+            </a:r>
+            <a:endParaRPr lang="en-US" sz="750" b="0" strike="noStrike" spc="-1">
               <a:solidFill>
                 <a:srgbClr val="FFFFFF"/>
               </a:solidFill>
@@ -8940,7 +10777,7 @@
                 <a:latin typeface="Georgia"/>
                 <a:ea typeface="Georgia"/>
               </a:rPr>
-              <a:t>117</a:t>
+              <a:t>47</a:t>
             </a:r>
             <a:endParaRPr lang="en-US" sz="2800" b="0" strike="noStrike" spc="-1">
               <a:solidFill>
@@ -9126,7 +10963,7 @@
                 <a:latin typeface="Georgia"/>
                 <a:ea typeface="Georgia"/>
               </a:rPr>
-              <a:t>239</a:t>
+              <a:t>59</a:t>
             </a:r>
             <a:endParaRPr lang="en-US" sz="2800" b="0" strike="noStrike" spc="-1">
               <a:solidFill>
@@ -9684,7 +11521,7 @@
                 <a:latin typeface="Georgia"/>
                 <a:ea typeface="Georgia"/>
               </a:rPr>
-              <a:t>13</a:t>
+              <a:t>10</a:t>
             </a:r>
             <a:endParaRPr lang="en-US" sz="2800" b="0" strike="noStrike" spc="-1">
               <a:solidFill>
@@ -12809,7 +14646,7 @@
                 <a:latin typeface="Calibri"/>
                 <a:ea typeface="Calibri"/>
               </a:rPr>
-              <a:t>Each phase shipped iteratively — visual QA on mobile, fix, push. ~25 git commits over the full build.</a:t>
+              <a:t>Each phase shipped iteratively — visual QA on mobile, fix, push. 245+ git commits over the full build — the second half almost all source-fidelity verification (next section).</a:t>
             </a:r>
             <a:endParaRPr lang="en-US" sz="1000" b="0" strike="noStrike" spc="-1">
               <a:solidFill>
@@ -14394,7 +16231,7 @@
                 <a:latin typeface="Calibri"/>
                 <a:ea typeface="Calibri"/>
               </a:rPr>
-              <a:t>GitHub Pages · Single bundled HTML — zero build pipeline</a:t>
+              <a:t>GitHub Pages · viewer.html (single-file) + index.html (modular) — zero build pipeline</a:t>
             </a:r>
             <a:endParaRPr lang="en-US" sz="1000" b="0" strike="noStrike" spc="-1">
               <a:solidFill>
@@ -15014,7 +16851,7 @@
                 <a:latin typeface="Calibri"/>
                 <a:ea typeface="Calibri"/>
               </a:rPr>
-              <a:t>13-tier hierarchy</a:t>
+              <a:t>10-tier hierarchy</a:t>
             </a:r>
             <a:endParaRPr lang="en-US" sz="1100" b="0" strike="noStrike" spc="-1">
               <a:solidFill>
@@ -15078,7 +16915,7 @@
                 <a:latin typeface="Calibri"/>
                 <a:ea typeface="Calibri"/>
               </a:rPr>
-              <a:t>Madhva's tāratamya — a strict hierarchy from Paramātman down to tāmoyogyas. Each tier is color-coded so the rank is visible at a glance.</a:t>
+              <a:t>Madhva's tāratamya — a strict hierarchy from Parabrahma down to Phala. Each tier is color-coded so the rank is visible at a glance.</a:t>
             </a:r>
             <a:endParaRPr lang="en-US" sz="950" b="0" strike="noStrike" spc="-1">
               <a:solidFill>
@@ -17154,7 +18991,7 @@
                 <a:latin typeface="Noto Sans Devanagari"/>
                 <a:cs typeface="Noto Sans Devanagari"/>
               </a:rPr>
-              <a:t>भगवद्गीता </a:t>
+              <a:t xml:space="preserve">भगवद्गीता </a:t>
             </a:r>
             <a:r>
               <a:rPr lang="en-US" sz="900" b="0" strike="noStrike" spc="-1">
@@ -17164,7 +19001,7 @@
                 <a:latin typeface="Noto Sans Devanagari"/>
                 <a:ea typeface="Noto Sans Devanagari"/>
               </a:rPr>
-              <a:t>· </a:t>
+              <a:t xml:space="preserve">· </a:t>
             </a:r>
             <a:r>
               <a:rPr lang="hi-IN" sz="900" b="0" strike="noStrike" spc="-1">
@@ -17493,7 +19330,7 @@
                 <a:latin typeface="Noto Sans Devanagari"/>
                 <a:cs typeface="Noto Sans Devanagari"/>
               </a:rPr>
-              <a:t>भगवद् गीता </a:t>
+              <a:t xml:space="preserve">भगवद् गीता </a:t>
             </a:r>
             <a:r>
               <a:rPr lang="en-US" sz="900" b="0" strike="noStrike" spc="-1">
@@ -17503,7 +19340,7 @@
                 <a:latin typeface="Noto Sans Devanagari"/>
                 <a:ea typeface="Noto Sans Devanagari"/>
               </a:rPr>
-              <a:t>· </a:t>
+              <a:t xml:space="preserve">· </a:t>
             </a:r>
             <a:r>
               <a:rPr lang="hi-IN" sz="900" b="0" strike="noStrike" spc="-1">
@@ -17832,7 +19669,7 @@
                 <a:latin typeface="Noto Sans Kannada"/>
                 <a:cs typeface="Noto Sans Kannada"/>
               </a:rPr>
-              <a:t>ಭಗವದ್ಗೀತಾ </a:t>
+              <a:t xml:space="preserve">ಭಗವದ್ಗೀತಾ </a:t>
             </a:r>
             <a:r>
               <a:rPr lang="en-US" sz="900" b="0" strike="noStrike" spc="-1">
@@ -17842,7 +19679,7 @@
                 <a:latin typeface="Noto Sans Kannada"/>
                 <a:ea typeface="Noto Sans Kannada"/>
               </a:rPr>
-              <a:t>· </a:t>
+              <a:t xml:space="preserve">· </a:t>
             </a:r>
             <a:r>
               <a:rPr lang="hi-IN" sz="900" b="0" strike="noStrike" spc="-1">
@@ -17986,7 +19823,7 @@
                 </a:solidFill>
                 <a:latin typeface="Calibri"/>
               </a:rPr>
-              <a:t>Key principle: </a:t>
+              <a:t xml:space="preserve">Key principle: </a:t>
             </a:r>
             <a:r>
               <a:rPr lang="en-US" sz="1000" b="0" strike="noStrike" spc="-1">
@@ -24890,7 +26727,7 @@
                 <a:latin typeface="Calibri"/>
                 <a:ea typeface="Calibri"/>
               </a:rPr>
-              <a:t>File Architecture</a:t>
+              <a:t>OCR Garbling</a:t>
             </a:r>
             <a:endParaRPr lang="en-US" sz="900" b="0" strike="noStrike" spc="-1">
               <a:solidFill>
@@ -25018,7 +26855,7 @@
                 <a:latin typeface="Calibri"/>
                 <a:ea typeface="Calibri"/>
               </a:rPr>
-              <a:t>Single-file constraint meant all data + logic + UI in one HTML</a:t>
+              <a:t>Legacy Kannada font scan garbled Bannanje's parenthesized English glosses into unreadable byte sequences</a:t>
             </a:r>
             <a:endParaRPr lang="en-US" sz="850" b="0" strike="noStrike" spc="-1">
               <a:solidFill>
@@ -25146,7 +26983,7 @@
                 <a:latin typeface="Calibri"/>
                 <a:ea typeface="Calibri"/>
               </a:rPr>
-              <a:t>Inline JS data objects; no bundler; iterative patching with Python/sed for surgical edits; node syntax-check after each patch</a:t>
+              <a:t>Vision-read all 476 source pages against bannanje_kn.js — zero body-text errors; ~265 garbled glosses fixed and propagated to all 4 languages</a:t>
             </a:r>
             <a:endParaRPr lang="en-US" sz="850" b="0" strike="noStrike" spc="-1">
               <a:solidFill>

</xml_diff>